<commit_message>
whimzmaxx decks: corrected duct tape commercial + storyboard, Diary restitch
Co-Authored-By: Claude Opus 5.5 <noreply@anthropic.com>
Claude-Session: https://claude.ai/code/session_013FY3ZG8DLVai1ZwG5sxxN1
</commit_message>
<xml_diff>
--- a/whimzmaxx/decks/A-Duct-Tape-Commercial.pptx
+++ b/whimzmaxx/decks/A-Duct-Tape-Commercial.pptx
@@ -115,7 +115,7 @@
   <p:extLst>
     <p:ext uri="{521415D9-36F7-43E2-AB2F-B90AF26B5E84}">
       <p14:sectionLst xmlns:p14="http://schemas.microsoft.com/office/powerpoint/2010/main">
-        <p14:section name="A duct tape commercial" id="{48a5024c-3015-70a0-14b8-66aff389951b}">
+        <p14:section name="A duct tape commercial" id="{8c48b666-be34-ba5b-c8c6-0f0c57f83389}">
           <p14:sldIdLst>
             <p14:sldId id="256"/>
             <p14:sldId id="257"/>
@@ -124,7 +124,7 @@
             <p14:sldId id="260"/>
           </p14:sldIdLst>
         </p14:section>
-        <p14:section name="The circle instead" id="{3538f430-dd46-4471-04d5-f37b27618e1f}">
+        <p14:section name="The circle instead" id="{6420391d-be74-a2dc-e3a2-9f43f735ed87}">
           <p14:sldIdLst>
             <p14:sldId id="261"/>
             <p14:sldId id="262"/>
@@ -624,7 +624,7 @@
           <a:p>
             <a:r>
               <a:rPr lang="en-US" dirty="0"/>
-              <a:t>Method: ffmpeg pulled one frame per second; every on-screen word was read off the frames. The spoken words come from the ad's burned-in captions, which show a few words at a time, so some phrases are partial. The audio itself wasn't transcribed (no speech-to-text in this workspace).</a:t>
+              <a:t>Method (corrected 10/26 11:15pm): the first pass read one frame per second and missed words; it also put a Gemini line in the ad that isn't there. Now every caption change is read at 6–15 fps (tools/ad/captions.py plus caption-strip sheets), including where the captions move up the screen. Full transcript: docs/ads/perplexity-computer-transcript.md. Two stretches (13–17 s, 23–31 s) carry graphics but no captions; the audio there wasn't transcribed (no speech-to-text in this workspace).</a:t>
             </a:r>
             <a:endParaRPr lang="en-US" dirty="0"/>
           </a:p>
@@ -2164,7 +2164,7 @@
                 <a:ea typeface="Century Schoolbook" pitchFamily="34" charset="-122"/>
                 <a:cs typeface="Century Schoolbook" pitchFamily="34" charset="-120"/>
               </a:rPr>
-              <a:t>68</a:t>
+              <a:t>411</a:t>
             </a:r>
             <a:endParaRPr lang="en-US" sz="3000" dirty="0"/>
           </a:p>
@@ -2200,7 +2200,7 @@
                   <a:schemeClr val="tx2"/>
                 </a:solidFill>
               </a:rPr>
-              <a:t>frames read, one per second</a:t>
+              <a:t>frames read, six per second</a:t>
             </a:r>
             <a:endParaRPr lang="en-US" sz="1400" dirty="0"/>
           </a:p>
@@ -2632,7 +2632,7 @@
                             <a:srgbClr val="17181D"/>
                           </a:solidFill>
                         </a:rPr>
-                        <a:t>0–5 s</a:t>
+                        <a:t>1–5 s</a:t>
                       </a:r>
                       <a:endParaRPr lang="en-US" sz="1100" dirty="0"/>
                     </a:p>
@@ -2690,7 +2690,7 @@
                             <a:srgbClr val="17181D"/>
                           </a:solidFill>
                         </a:rPr>
-                        <a:t>“the first AI that works” · “AI was supposed to…” · “Work, meet Computer”</a:t>
+                        <a:t>“This is the first AI tool that works the way AI was actually supposed to: Perplexity Computer”</a:t>
                       </a:r>
                       <a:endParaRPr lang="en-US" sz="1100" dirty="0"/>
                     </a:p>
@@ -2750,7 +2750,7 @@
                             <a:srgbClr val="17181D"/>
                           </a:solidFill>
                         </a:rPr>
-                        <a:t>6–12 s</a:t>
+                        <a:t>6–13 s</a:t>
                       </a:r>
                       <a:endParaRPr lang="en-US" sz="1100" dirty="0"/>
                     </a:p>
@@ -2808,7 +2808,7 @@
                             <a:srgbClr val="17181D"/>
                           </a:solidFill>
                         </a:rPr>
-                        <a:t>Task: build a “Creative Project Pricing Calculator” for freelancers</a:t>
+                        <a:t>Task: “build a beautiful pricing calculator to help freelancers estimate pricing and generate proposals, instead of using just one model”</a:t>
                       </a:r>
                       <a:endParaRPr lang="en-US" sz="1100" dirty="0"/>
                     </a:p>
@@ -2868,7 +2868,7 @@
                             <a:srgbClr val="17181D"/>
                           </a:solidFill>
                         </a:rPr>
-                        <a:t>13–18 s</a:t>
+                        <a:t>13–17 s</a:t>
                       </a:r>
                       <a:endParaRPr lang="en-US" sz="1100" dirty="0"/>
                     </a:p>
@@ -2926,7 +2926,7 @@
                             <a:srgbClr val="17181D"/>
                           </a:solidFill>
                         </a:rPr>
-                        <a:t>One model (Gemini) is “great, but not so much for design”</a:t>
+                        <a:t>Graphic, no captions: Gemini 3 — Deep Research, Visual Design, Complex Reasoning, Speed, Video Generation</a:t>
                       </a:r>
                       <a:endParaRPr lang="en-US" sz="1100" dirty="0"/>
                     </a:p>
@@ -2986,7 +2986,7 @@
                             <a:srgbClr val="17181D"/>
                           </a:solidFill>
                         </a:rPr>
-                        <a:t>19–33 s</a:t>
+                        <a:t>18–31 s</a:t>
                       </a:r>
                       <a:endParaRPr lang="en-US" sz="1100" dirty="0"/>
                     </a:p>
@@ -3044,7 +3044,7 @@
                             <a:srgbClr val="17181D"/>
                           </a:solidFill>
                         </a:rPr>
-                        <a:t>Computer “breaks it down” into subtasks, “orchestrates 19 AI models”: Gemini research, Grok math, Nano Banana design, Claude Opus reasoning</a:t>
+                        <a:t>“breaks it down into parallel subtasks and orchestrates 19 specialized AI models” · graphic: research, fast calculations, design, advanced reasoning</a:t>
                       </a:r>
                       <a:endParaRPr lang="en-US" sz="1100" dirty="0"/>
                     </a:p>
@@ -3104,7 +3104,7 @@
                             <a:srgbClr val="17181D"/>
                           </a:solidFill>
                         </a:rPr>
-                        <a:t>34–40 s</a:t>
+                        <a:t>31–42 s</a:t>
                       </a:r>
                       <a:endParaRPr lang="en-US" sz="1100" dirty="0"/>
                     </a:p>
@@ -3162,7 +3162,7 @@
                             <a:srgbClr val="17181D"/>
                           </a:solidFill>
                         </a:rPr>
-                        <a:t>“like your team of experts”: CPA, designer, developer, copywriter, analyst</a:t>
+                        <a:t>“highest possible quality” · “your personal team of experts who trained their whole lives for their specific job” (CPA, Senior Designer, Software Developer icons)</a:t>
                       </a:r>
                       <a:endParaRPr lang="en-US" sz="1100" dirty="0"/>
                     </a:p>
@@ -3222,7 +3222,7 @@
                             <a:srgbClr val="17181D"/>
                           </a:solidFill>
                         </a:rPr>
-                        <a:t>41–50 s</a:t>
+                        <a:t>42–52 s</a:t>
                       </a:r>
                       <a:endParaRPr lang="en-US" sz="1100" dirty="0"/>
                     </a:p>
@@ -3280,7 +3280,7 @@
                             <a:srgbClr val="17181D"/>
                           </a:solidFill>
                         </a:rPr>
-                        <a:t>Runs your business: supply tracking, P&amp;L dashboards, a $71,400 proposal</a:t>
+                        <a:t>“register your business, automate emails, monitor supply” · “a custom app tailored to my unique sales process” ($71,400 on screen)</a:t>
                       </a:r>
                       <a:endParaRPr lang="en-US" sz="1100" dirty="0"/>
                     </a:p>
@@ -3340,7 +3340,7 @@
                             <a:srgbClr val="17181D"/>
                           </a:solidFill>
                         </a:rPr>
-                        <a:t>51–66 s</a:t>
+                        <a:t>52–65 s</a:t>
                       </a:r>
                       <a:endParaRPr lang="en-US" sz="1100" dirty="0"/>
                     </a:p>
@@ -3398,7 +3398,7 @@
                             <a:srgbClr val="17181D"/>
                           </a:solidFill>
                         </a:rPr>
-                        <a:t>“thousands of apps” (Dropbox, Figma, Notion…) · “context of all my work” · “until now”</a:t>
+                        <a:t>“thousands of connectors to apps like Dropbox, Figma, Notion” · “the full context of all my work, across all my apps … until now”</a:t>
                       </a:r>
                       <a:endParaRPr lang="en-US" sz="1100" dirty="0"/>
                     </a:p>
@@ -3458,7 +3458,7 @@
                             <a:srgbClr val="17181D"/>
                           </a:solidFill>
                         </a:rPr>
-                        <a:t>67 s</a:t>
+                        <a:t>65–67 s</a:t>
                       </a:r>
                       <a:endParaRPr lang="en-US" sz="1100" dirty="0"/>
                     </a:p>
@@ -3516,7 +3516,7 @@
                             <a:srgbClr val="17181D"/>
                           </a:solidFill>
                         </a:rPr>
-                        <a:t>“try Computer.”</a:t>
+                        <a:t>“Click the link below to try Computer.”</a:t>
                       </a:r>
                       <a:endParaRPr lang="en-US" sz="1100" dirty="0"/>
                     </a:p>
@@ -3862,7 +3862,7 @@
                   <a:schemeClr val="accent2"/>
                 </a:solidFill>
               </a:rPr>
-              <a:t>A CPA’s, a designer’s, a developer’s whole lives become five gray avatars. Nobody in the ad is paid.</a:t>
+              <a:t>“Experts who trained their whole lives” become gray icons. Nobody in the ad is paid.</a:t>
             </a:r>
             <a:endParaRPr lang="en-US" sz="1300" dirty="0"/>
           </a:p>

</xml_diff>